<commit_message>
fix images for README.md
</commit_message>
<xml_diff>
--- a/PaMagiTe.pptx
+++ b/PaMagiTe.pptx
@@ -265,7 +265,7 @@
           <a:p>
             <a:fld id="{BA43EDD6-7778-4796-87E1-00226B23BBEA}" type="datetimeFigureOut">
               <a:rPr lang="en-US" smtClean="0"/>
-              <a:t>12/28/2020</a:t>
+              <a:t>2/13/2022</a:t>
             </a:fld>
             <a:endParaRPr lang="en-US"/>
           </a:p>
@@ -464,7 +464,7 @@
           <a:p>
             <a:fld id="{BA43EDD6-7778-4796-87E1-00226B23BBEA}" type="datetimeFigureOut">
               <a:rPr lang="en-US" smtClean="0"/>
-              <a:t>12/28/2020</a:t>
+              <a:t>2/13/2022</a:t>
             </a:fld>
             <a:endParaRPr lang="en-US"/>
           </a:p>
@@ -644,7 +644,7 @@
           <a:p>
             <a:fld id="{BA43EDD6-7778-4796-87E1-00226B23BBEA}" type="datetimeFigureOut">
               <a:rPr lang="en-US" smtClean="0"/>
-              <a:t>12/28/2020</a:t>
+              <a:t>2/13/2022</a:t>
             </a:fld>
             <a:endParaRPr lang="en-US"/>
           </a:p>
@@ -762,7 +762,7 @@
           <a:p>
             <a:fld id="{BA43EDD6-7778-4796-87E1-00226B23BBEA}" type="datetimeFigureOut">
               <a:rPr lang="en-US" smtClean="0"/>
-              <a:t>12/28/2020</a:t>
+              <a:t>2/13/2022</a:t>
             </a:fld>
             <a:endParaRPr lang="en-US"/>
           </a:p>
@@ -932,7 +932,7 @@
           <a:p>
             <a:fld id="{BA43EDD6-7778-4796-87E1-00226B23BBEA}" type="datetimeFigureOut">
               <a:rPr lang="en-US" smtClean="0"/>
-              <a:t>12/28/2020</a:t>
+              <a:t>2/13/2022</a:t>
             </a:fld>
             <a:endParaRPr lang="en-US"/>
           </a:p>
@@ -1176,7 +1176,7 @@
           <a:p>
             <a:fld id="{BA43EDD6-7778-4796-87E1-00226B23BBEA}" type="datetimeFigureOut">
               <a:rPr lang="en-US" smtClean="0"/>
-              <a:t>12/28/2020</a:t>
+              <a:t>2/13/2022</a:t>
             </a:fld>
             <a:endParaRPr lang="en-US"/>
           </a:p>
@@ -1408,7 +1408,7 @@
           <a:p>
             <a:fld id="{BA43EDD6-7778-4796-87E1-00226B23BBEA}" type="datetimeFigureOut">
               <a:rPr lang="en-US" smtClean="0"/>
-              <a:t>12/28/2020</a:t>
+              <a:t>2/13/2022</a:t>
             </a:fld>
             <a:endParaRPr lang="en-US"/>
           </a:p>
@@ -1775,7 +1775,7 @@
           <a:p>
             <a:fld id="{BA43EDD6-7778-4796-87E1-00226B23BBEA}" type="datetimeFigureOut">
               <a:rPr lang="en-US" smtClean="0"/>
-              <a:t>12/28/2020</a:t>
+              <a:t>2/13/2022</a:t>
             </a:fld>
             <a:endParaRPr lang="en-US"/>
           </a:p>
@@ -1893,7 +1893,7 @@
           <a:p>
             <a:fld id="{BA43EDD6-7778-4796-87E1-00226B23BBEA}" type="datetimeFigureOut">
               <a:rPr lang="en-US" smtClean="0"/>
-              <a:t>12/28/2020</a:t>
+              <a:t>2/13/2022</a:t>
             </a:fld>
             <a:endParaRPr lang="en-US"/>
           </a:p>
@@ -1988,7 +1988,7 @@
           <a:p>
             <a:fld id="{BA43EDD6-7778-4796-87E1-00226B23BBEA}" type="datetimeFigureOut">
               <a:rPr lang="en-US" smtClean="0"/>
-              <a:t>12/28/2020</a:t>
+              <a:t>2/13/2022</a:t>
             </a:fld>
             <a:endParaRPr lang="en-US"/>
           </a:p>
@@ -2265,7 +2265,7 @@
           <a:p>
             <a:fld id="{BA43EDD6-7778-4796-87E1-00226B23BBEA}" type="datetimeFigureOut">
               <a:rPr lang="en-US" smtClean="0"/>
-              <a:t>12/28/2020</a:t>
+              <a:t>2/13/2022</a:t>
             </a:fld>
             <a:endParaRPr lang="en-US"/>
           </a:p>
@@ -2522,7 +2522,7 @@
           <a:p>
             <a:fld id="{BA43EDD6-7778-4796-87E1-00226B23BBEA}" type="datetimeFigureOut">
               <a:rPr lang="en-US" smtClean="0"/>
-              <a:t>12/28/2020</a:t>
+              <a:t>2/13/2022</a:t>
             </a:fld>
             <a:endParaRPr lang="en-US"/>
           </a:p>
@@ -2735,7 +2735,7 @@
           <a:p>
             <a:fld id="{BA43EDD6-7778-4796-87E1-00226B23BBEA}" type="datetimeFigureOut">
               <a:rPr lang="en-US" smtClean="0"/>
-              <a:t>12/28/2020</a:t>
+              <a:t>2/13/2022</a:t>
             </a:fld>
             <a:endParaRPr lang="en-US"/>
           </a:p>
@@ -3223,7 +3223,7 @@
           <a:p>
             <a:pPr algn="l"/>
             <a:r>
-              <a:rPr lang="en-US" b="1" dirty="0" err="1" smtClean="0">
+              <a:rPr lang="en-US" b="1" dirty="0" smtClean="0">
                 <a:solidFill>
                   <a:schemeClr val="tx2">
                     <a:lumMod val="75000"/>
@@ -3232,17 +3232,6 @@
                 <a:latin typeface="Calibri Light (Заголовки)"/>
               </a:rPr>
               <a:t>PaMagiTe</a:t>
-            </a:r>
-            <a:r>
-              <a:rPr lang="en-US" b="1" dirty="0" smtClean="0">
-                <a:solidFill>
-                  <a:schemeClr val="tx2">
-                    <a:lumMod val="75000"/>
-                  </a:schemeClr>
-                </a:solidFill>
-                <a:latin typeface="Calibri Light (Заголовки)"/>
-              </a:rPr>
-              <a:t/>
             </a:r>
             <a:br>
               <a:rPr lang="en-US" b="1" dirty="0" smtClean="0">
@@ -3331,18 +3320,7 @@
                 </a:solidFill>
                 <a:latin typeface="+mj-lt"/>
               </a:rPr>
-              <a:t>@</a:t>
-            </a:r>
-            <a:r>
-              <a:rPr lang="en-US" dirty="0" err="1" smtClean="0">
-                <a:solidFill>
-                  <a:schemeClr val="accent1">
-                    <a:lumMod val="75000"/>
-                  </a:schemeClr>
-                </a:solidFill>
-                <a:latin typeface="+mj-lt"/>
-              </a:rPr>
-              <a:t>StudentsHouseBot</a:t>
+              <a:t>@StudentsHouseBot</a:t>
             </a:r>
             <a:endParaRPr lang="en-US" dirty="0" smtClean="0">
               <a:solidFill>
@@ -3415,15 +3393,7 @@
           <a:p>
             <a:r>
               <a:rPr lang="en-US" dirty="0" smtClean="0"/>
-              <a:t>@</a:t>
-            </a:r>
-            <a:r>
-              <a:rPr lang="en-US" dirty="0" err="1" smtClean="0"/>
-              <a:t>StudentsHouseBot</a:t>
-            </a:r>
-            <a:r>
-              <a:rPr lang="en-US" dirty="0" smtClean="0"/>
-              <a:t/>
+              <a:t>@StudentsHouseBot</a:t>
             </a:r>
             <a:br>
               <a:rPr lang="en-US" dirty="0" smtClean="0"/>
@@ -3607,15 +3577,7 @@
           <a:p>
             <a:r>
               <a:rPr lang="en-US" dirty="0" smtClean="0"/>
-              <a:t>@</a:t>
-            </a:r>
-            <a:r>
-              <a:rPr lang="en-US" dirty="0" err="1" smtClean="0"/>
-              <a:t>StudentsHouseBot</a:t>
-            </a:r>
-            <a:r>
-              <a:rPr lang="en-US" dirty="0" smtClean="0"/>
-              <a:t/>
+              <a:t>@StudentsHouseBot</a:t>
             </a:r>
             <a:br>
               <a:rPr lang="en-US" dirty="0" smtClean="0"/>
@@ -3799,15 +3761,7 @@
           <a:p>
             <a:r>
               <a:rPr lang="en-US" dirty="0" smtClean="0"/>
-              <a:t>@</a:t>
-            </a:r>
-            <a:r>
-              <a:rPr lang="en-US" dirty="0" err="1" smtClean="0"/>
-              <a:t>StudentsHouseBot</a:t>
-            </a:r>
-            <a:r>
-              <a:rPr lang="en-US" dirty="0" smtClean="0"/>
-              <a:t/>
+              <a:t>@StudentsHouseBot</a:t>
             </a:r>
             <a:br>
               <a:rPr lang="en-US" dirty="0" smtClean="0"/>
@@ -4031,15 +3985,7 @@
           <a:p>
             <a:r>
               <a:rPr lang="en-US" dirty="0" smtClean="0"/>
-              <a:t>@</a:t>
-            </a:r>
-            <a:r>
-              <a:rPr lang="en-US" dirty="0" err="1" smtClean="0"/>
-              <a:t>StudentsHouseBot</a:t>
-            </a:r>
-            <a:r>
-              <a:rPr lang="en-US" dirty="0" smtClean="0"/>
-              <a:t/>
+              <a:t>@StudentsHouseBot</a:t>
             </a:r>
             <a:br>
               <a:rPr lang="en-US" dirty="0" smtClean="0"/>
@@ -4263,15 +4209,7 @@
           <a:p>
             <a:r>
               <a:rPr lang="en-US" dirty="0" smtClean="0"/>
-              <a:t>@</a:t>
-            </a:r>
-            <a:r>
-              <a:rPr lang="en-US" dirty="0" err="1" smtClean="0"/>
-              <a:t>StudentsHouseBot</a:t>
-            </a:r>
-            <a:r>
-              <a:rPr lang="en-US" dirty="0" smtClean="0"/>
-              <a:t/>
+              <a:t>@StudentsHouseBot</a:t>
             </a:r>
             <a:br>
               <a:rPr lang="en-US" dirty="0" smtClean="0"/>
@@ -4455,15 +4393,7 @@
           <a:p>
             <a:r>
               <a:rPr lang="en-US" dirty="0" smtClean="0"/>
-              <a:t>@</a:t>
-            </a:r>
-            <a:r>
-              <a:rPr lang="en-US" dirty="0" err="1" smtClean="0"/>
-              <a:t>StudentsHouseBot</a:t>
-            </a:r>
-            <a:r>
-              <a:rPr lang="en-US" dirty="0" smtClean="0"/>
-              <a:t/>
+              <a:t>@StudentsHouseBot</a:t>
             </a:r>
             <a:br>
               <a:rPr lang="en-US" dirty="0" smtClean="0"/>
@@ -4657,15 +4587,7 @@
           <a:p>
             <a:r>
               <a:rPr lang="en-US" dirty="0" smtClean="0"/>
-              <a:t>@</a:t>
-            </a:r>
-            <a:r>
-              <a:rPr lang="en-US" dirty="0" err="1" smtClean="0"/>
-              <a:t>StudentsHouseBot</a:t>
-            </a:r>
-            <a:r>
-              <a:rPr lang="en-US" dirty="0" smtClean="0"/>
-              <a:t/>
+              <a:t>@StudentsHouseBot</a:t>
             </a:r>
             <a:br>
               <a:rPr lang="en-US" dirty="0" smtClean="0"/>
@@ -4897,15 +4819,7 @@
           <a:p>
             <a:r>
               <a:rPr lang="en-US" dirty="0" smtClean="0"/>
-              <a:t>@</a:t>
-            </a:r>
-            <a:r>
-              <a:rPr lang="en-US" dirty="0" err="1" smtClean="0"/>
-              <a:t>StudentsHouseBot</a:t>
-            </a:r>
-            <a:r>
-              <a:rPr lang="en-US" dirty="0" smtClean="0"/>
-              <a:t/>
+              <a:t>@StudentsHouseBot</a:t>
             </a:r>
             <a:br>
               <a:rPr lang="en-US" dirty="0" smtClean="0"/>
@@ -4920,11 +4834,7 @@
             </a:r>
             <a:r>
               <a:rPr lang="ru-RU" sz="4000" dirty="0" smtClean="0"/>
-              <a:t>как и получать сообщение в </a:t>
-            </a:r>
-            <a:r>
-              <a:rPr lang="ru-RU" sz="4000" dirty="0" smtClean="0"/>
-              <a:t>тек</a:t>
+              <a:t>как и получать сообщение в тек</a:t>
             </a:r>
             <a:r>
               <a:rPr lang="ru-RU" sz="4000" dirty="0"/>
@@ -4932,11 +4842,7 @@
             </a:r>
             <a:r>
               <a:rPr lang="ru-RU" sz="4000" dirty="0" smtClean="0"/>
-              <a:t>щем </a:t>
-            </a:r>
-            <a:r>
-              <a:rPr lang="ru-RU" sz="4000" dirty="0" smtClean="0"/>
-              <a:t>времени</a:t>
+              <a:t>щем времени</a:t>
             </a:r>
             <a:endParaRPr lang="ru-RU" sz="4000" dirty="0"/>
           </a:p>
@@ -5143,15 +5049,7 @@
           <a:p>
             <a:r>
               <a:rPr lang="en-US" dirty="0" smtClean="0"/>
-              <a:t>@</a:t>
-            </a:r>
-            <a:r>
-              <a:rPr lang="en-US" dirty="0" err="1" smtClean="0"/>
-              <a:t>StudentsHouseBot</a:t>
-            </a:r>
-            <a:r>
-              <a:rPr lang="en-US" dirty="0" smtClean="0"/>
-              <a:t/>
+              <a:t>@StudentsHouseBot</a:t>
             </a:r>
             <a:br>
               <a:rPr lang="en-US" dirty="0" smtClean="0"/>
@@ -5206,19 +5104,7 @@
             </a:r>
             <a:r>
               <a:rPr lang="ru-RU" dirty="0" smtClean="0"/>
-              <a:t>студент</a:t>
-            </a:r>
-            <a:r>
-              <a:rPr lang="ru-RU" dirty="0" smtClean="0"/>
-              <a:t>ам</a:t>
-            </a:r>
-            <a:r>
-              <a:rPr lang="ru-RU" dirty="0" smtClean="0"/>
-              <a:t> </a:t>
-            </a:r>
-            <a:r>
-              <a:rPr lang="ru-RU" dirty="0" smtClean="0"/>
-              <a:t>одного факультета</a:t>
+              <a:t>студентам одного факультета</a:t>
             </a:r>
             <a:endParaRPr lang="ru-RU" dirty="0"/>
           </a:p>
@@ -5293,15 +5179,7 @@
           <a:p>
             <a:r>
               <a:rPr lang="en-US" dirty="0" smtClean="0"/>
-              <a:t>@</a:t>
-            </a:r>
-            <a:r>
-              <a:rPr lang="en-US" dirty="0" err="1" smtClean="0"/>
-              <a:t>StudentsHouseBot</a:t>
-            </a:r>
-            <a:r>
-              <a:rPr lang="en-US" dirty="0" smtClean="0"/>
-              <a:t/>
+              <a:t>@StudentsHouseBot</a:t>
             </a:r>
             <a:br>
               <a:rPr lang="en-US" dirty="0" smtClean="0"/>
@@ -5386,11 +5264,7 @@
             </a:r>
             <a:r>
               <a:rPr lang="ru-RU" dirty="0" smtClean="0"/>
-              <a:t>студентам </a:t>
-            </a:r>
-            <a:r>
-              <a:rPr lang="ru-RU" dirty="0" smtClean="0"/>
-              <a:t>одного факультета</a:t>
+              <a:t>студентам одного факультета</a:t>
             </a:r>
             <a:endParaRPr lang="ru-RU" dirty="0"/>
           </a:p>
@@ -5468,7 +5342,7 @@
               <a:t>@</a:t>
             </a:r>
             <a:r>
-              <a:rPr lang="en-US" sz="3600" dirty="0" err="1" smtClean="0"/>
+              <a:rPr lang="en-US" sz="3600" dirty="0" smtClean="0"/>
               <a:t>StudentsHouseBot</a:t>
             </a:r>
             <a:r>
@@ -5833,15 +5707,7 @@
           <a:p>
             <a:r>
               <a:rPr lang="en-US" dirty="0" smtClean="0"/>
-              <a:t>@</a:t>
-            </a:r>
-            <a:r>
-              <a:rPr lang="en-US" dirty="0" err="1" smtClean="0"/>
-              <a:t>StudentsHouseBot</a:t>
-            </a:r>
-            <a:r>
-              <a:rPr lang="en-US" dirty="0" smtClean="0"/>
-              <a:t/>
+              <a:t>@StudentsHouseBot</a:t>
             </a:r>
             <a:br>
               <a:rPr lang="en-US" dirty="0" smtClean="0"/>
@@ -5926,11 +5792,7 @@
             </a:r>
             <a:r>
               <a:rPr lang="ru-RU" dirty="0" smtClean="0"/>
-              <a:t>студентам </a:t>
-            </a:r>
-            <a:r>
-              <a:rPr lang="ru-RU" dirty="0" smtClean="0"/>
-              <a:t>одного факультета</a:t>
+              <a:t>студентам одного факультета</a:t>
             </a:r>
             <a:endParaRPr lang="ru-RU" dirty="0"/>
           </a:p>
@@ -6051,15 +5913,7 @@
           <a:p>
             <a:r>
               <a:rPr lang="en-US" dirty="0" smtClean="0"/>
-              <a:t>@</a:t>
-            </a:r>
-            <a:r>
-              <a:rPr lang="en-US" dirty="0" err="1" smtClean="0"/>
-              <a:t>StudentsHouseBot</a:t>
-            </a:r>
-            <a:r>
-              <a:rPr lang="en-US" dirty="0" smtClean="0"/>
-              <a:t/>
+              <a:t>@StudentsHouseBot</a:t>
             </a:r>
             <a:br>
               <a:rPr lang="en-US" dirty="0" smtClean="0"/>
@@ -6144,11 +5998,7 @@
             </a:r>
             <a:r>
               <a:rPr lang="ru-RU" dirty="0" smtClean="0"/>
-              <a:t>студентам </a:t>
-            </a:r>
-            <a:r>
-              <a:rPr lang="ru-RU" dirty="0" smtClean="0"/>
-              <a:t>одного факультета</a:t>
+              <a:t>студентам одного факультета</a:t>
             </a:r>
             <a:endParaRPr lang="ru-RU" dirty="0"/>
           </a:p>
@@ -6326,15 +6176,7 @@
           <a:p>
             <a:r>
               <a:rPr lang="en-US" dirty="0" smtClean="0"/>
-              <a:t>@</a:t>
-            </a:r>
-            <a:r>
-              <a:rPr lang="en-US" dirty="0" err="1" smtClean="0"/>
-              <a:t>StudentsHouseBot</a:t>
-            </a:r>
-            <a:r>
-              <a:rPr lang="en-US" dirty="0" smtClean="0"/>
-              <a:t/>
+              <a:t>@StudentsHouseBot</a:t>
             </a:r>
             <a:br>
               <a:rPr lang="en-US" dirty="0" smtClean="0"/>
@@ -6419,11 +6261,7 @@
             </a:r>
             <a:r>
               <a:rPr lang="ru-RU" dirty="0" smtClean="0"/>
-              <a:t>студентам </a:t>
-            </a:r>
-            <a:r>
-              <a:rPr lang="ru-RU" dirty="0" smtClean="0"/>
-              <a:t>одного факультета</a:t>
+              <a:t>студентам одного факультета</a:t>
             </a:r>
             <a:endParaRPr lang="ru-RU" dirty="0"/>
           </a:p>
@@ -6657,15 +6495,7 @@
           <a:p>
             <a:r>
               <a:rPr lang="en-US" dirty="0" smtClean="0"/>
-              <a:t>@</a:t>
-            </a:r>
-            <a:r>
-              <a:rPr lang="en-US" dirty="0" err="1" smtClean="0"/>
-              <a:t>StudentsHouseBot</a:t>
-            </a:r>
-            <a:r>
-              <a:rPr lang="en-US" dirty="0" smtClean="0"/>
-              <a:t/>
+              <a:t>@StudentsHouseBot</a:t>
             </a:r>
             <a:br>
               <a:rPr lang="en-US" dirty="0" smtClean="0"/>
@@ -6687,7 +6517,7 @@
               <a:t>, </a:t>
             </a:r>
             <a:r>
-              <a:rPr lang="ru-RU" sz="4000" smtClean="0"/>
+              <a:rPr lang="ru-RU" sz="4000" dirty="0" smtClean="0"/>
               <a:t>помогайте развивать проект</a:t>
             </a:r>
             <a:endParaRPr lang="ru-RU" sz="4000" dirty="0"/>
@@ -6826,7 +6656,7 @@
               <a:t>@</a:t>
             </a:r>
             <a:r>
-              <a:rPr lang="en-US" sz="3600" dirty="0" err="1" smtClean="0"/>
+              <a:rPr lang="en-US" sz="3600" dirty="0" smtClean="0"/>
               <a:t>StudentsHouseBot</a:t>
             </a:r>
             <a:r>
@@ -7491,7 +7321,7 @@
               <a:t>@</a:t>
             </a:r>
             <a:r>
-              <a:rPr lang="en-US" sz="3600" dirty="0" err="1" smtClean="0"/>
+              <a:rPr lang="en-US" sz="3600" dirty="0" smtClean="0"/>
               <a:t>StudentsHouseBot</a:t>
             </a:r>
             <a:r>
@@ -8461,7 +8291,7 @@
               <a:t>@</a:t>
             </a:r>
             <a:r>
-              <a:rPr lang="en-US" sz="3600" dirty="0" err="1" smtClean="0"/>
+              <a:rPr lang="en-US" sz="3600" dirty="0" smtClean="0"/>
               <a:t>StudentsHouseBot</a:t>
             </a:r>
             <a:r>
@@ -9458,15 +9288,7 @@
           <a:p>
             <a:r>
               <a:rPr lang="en-US" dirty="0" smtClean="0"/>
-              <a:t>@</a:t>
-            </a:r>
-            <a:r>
-              <a:rPr lang="en-US" dirty="0" err="1" smtClean="0"/>
-              <a:t>StudentsHouseBot</a:t>
-            </a:r>
-            <a:r>
-              <a:rPr lang="en-US" dirty="0" smtClean="0"/>
-              <a:t/>
+              <a:t>@StudentsHouseBot</a:t>
             </a:r>
             <a:br>
               <a:rPr lang="en-US" dirty="0" smtClean="0"/>
@@ -9654,15 +9476,7 @@
           <a:p>
             <a:r>
               <a:rPr lang="en-US" dirty="0" smtClean="0"/>
-              <a:t>@</a:t>
-            </a:r>
-            <a:r>
-              <a:rPr lang="en-US" dirty="0" err="1" smtClean="0"/>
-              <a:t>StudentsHouseBot</a:t>
-            </a:r>
-            <a:r>
-              <a:rPr lang="en-US" dirty="0" smtClean="0"/>
-              <a:t/>
+              <a:t>@StudentsHouseBot</a:t>
             </a:r>
             <a:br>
               <a:rPr lang="en-US" dirty="0" smtClean="0"/>
@@ -9846,15 +9660,7 @@
           <a:p>
             <a:r>
               <a:rPr lang="en-US" dirty="0" smtClean="0"/>
-              <a:t>@</a:t>
-            </a:r>
-            <a:r>
-              <a:rPr lang="en-US" dirty="0" err="1" smtClean="0"/>
-              <a:t>StudentsHouseBot</a:t>
-            </a:r>
-            <a:r>
-              <a:rPr lang="en-US" dirty="0" smtClean="0"/>
-              <a:t/>
+              <a:t>@StudentsHouseBot</a:t>
             </a:r>
             <a:br>
               <a:rPr lang="en-US" dirty="0" smtClean="0"/>
@@ -10038,15 +9844,7 @@
           <a:p>
             <a:r>
               <a:rPr lang="en-US" dirty="0" smtClean="0"/>
-              <a:t>@</a:t>
-            </a:r>
-            <a:r>
-              <a:rPr lang="en-US" dirty="0" err="1" smtClean="0"/>
-              <a:t>StudentsHouseBot</a:t>
-            </a:r>
-            <a:r>
-              <a:rPr lang="en-US" dirty="0" smtClean="0"/>
-              <a:t/>
+              <a:t>@StudentsHouseBot</a:t>
             </a:r>
             <a:br>
               <a:rPr lang="en-US" dirty="0" smtClean="0"/>

</xml_diff>